<commit_message>
Update presentation with accurate jurisdiction lists
</commit_message>
<xml_diff>
--- a/digital-id-presentation.pptx
+++ b/digital-id-presentation.pptx
@@ -3099,16 +3099,16 @@
         </p:nvSpPr>
         <p:spPr>
           <a:xfrm>
-            <a:off x="457200" y="365760"/>
-            <a:ext cx="13716000" cy="731520"/>
-          </a:xfrm>
-          <a:prstGeom prst="rect">
-            <a:avLst/>
-          </a:prstGeom>
-          <a:noFill/>
-        </p:spPr>
-        <p:txBody>
-          <a:bodyPr wrap="square">
+            <a:off x="457200" y="274320"/>
+            <a:ext cx="13716000" cy="640080"/>
+          </a:xfrm>
+          <a:prstGeom prst="rect">
+            <a:avLst/>
+          </a:prstGeom>
+          <a:noFill/>
+        </p:spPr>
+        <p:txBody>
+          <a:bodyPr wrap="none">
             <a:spAutoFit/>
           </a:bodyPr>
           <a:lstStyle/>
@@ -3134,29 +3134,29 @@
         </p:nvSpPr>
         <p:spPr>
           <a:xfrm>
-            <a:off x="457200" y="1005840"/>
-            <a:ext cx="13716000" cy="457200"/>
-          </a:xfrm>
-          <a:prstGeom prst="rect">
-            <a:avLst/>
-          </a:prstGeom>
-          <a:noFill/>
-        </p:spPr>
-        <p:txBody>
-          <a:bodyPr wrap="none">
-            <a:spAutoFit/>
-          </a:bodyPr>
-          <a:lstStyle/>
-          <a:p>
-            <a:pPr>
-              <a:defRPr sz="2200">
+            <a:off x="457200" y="914400"/>
+            <a:ext cx="13716000" cy="365760"/>
+          </a:xfrm>
+          <a:prstGeom prst="rect">
+            <a:avLst/>
+          </a:prstGeom>
+          <a:noFill/>
+        </p:spPr>
+        <p:txBody>
+          <a:bodyPr wrap="none">
+            <a:spAutoFit/>
+          </a:bodyPr>
+          <a:lstStyle/>
+          <a:p>
+            <a:pPr>
+              <a:defRPr sz="1800">
                 <a:solidFill>
                   <a:srgbClr val="4ADE80"/>
                 </a:solidFill>
               </a:defRPr>
             </a:pPr>
             <a:r>
-              <a:t>Single Issuer Model - Government issues ONE digital credential per person (33 jurisdictions)</a:t>
+              <a:t>Single Issuer Model - Government issues ONE digital credential per person (41 jurisdictions)</a:t>
             </a:r>
           </a:p>
         </p:txBody>
@@ -3169,29 +3169,29 @@
         </p:nvSpPr>
         <p:spPr>
           <a:xfrm>
-            <a:off x="457200" y="1645920"/>
-            <a:ext cx="2286000" cy="365760"/>
-          </a:xfrm>
-          <a:prstGeom prst="rect">
-            <a:avLst/>
-          </a:prstGeom>
-          <a:noFill/>
-        </p:spPr>
-        <p:txBody>
-          <a:bodyPr wrap="none">
-            <a:spAutoFit/>
-          </a:bodyPr>
-          <a:lstStyle/>
-          <a:p>
-            <a:pPr>
-              <a:defRPr sz="1400" b="1">
-                <a:solidFill>
-                  <a:srgbClr val="E8C547"/>
-                </a:solidFill>
-              </a:defRPr>
-            </a:pPr>
-            <a:r>
-              <a:t>Americas:</a:t>
+            <a:off x="457200" y="1463040"/>
+            <a:ext cx="3840480" cy="365760"/>
+          </a:xfrm>
+          <a:prstGeom prst="rect">
+            <a:avLst/>
+          </a:prstGeom>
+          <a:noFill/>
+        </p:spPr>
+        <p:txBody>
+          <a:bodyPr wrap="none">
+            <a:spAutoFit/>
+          </a:bodyPr>
+          <a:lstStyle/>
+          <a:p>
+            <a:pPr>
+              <a:defRPr sz="1300">
+                <a:solidFill>
+                  <a:srgbClr val="FFFFFF"/>
+                </a:solidFill>
+              </a:defRPr>
+            </a:pPr>
+            <a:r>
+              <a:t>• Brazil</a:t>
             </a:r>
           </a:p>
         </p:txBody>
@@ -3204,8 +3204,8 @@
         </p:nvSpPr>
         <p:spPr>
           <a:xfrm>
-            <a:off x="2743200" y="1645920"/>
-            <a:ext cx="11430000" cy="365760"/>
+            <a:off x="457200" y="1783080"/>
+            <a:ext cx="3840480" cy="365760"/>
           </a:xfrm>
           <a:prstGeom prst="rect">
             <a:avLst/>
@@ -3226,7 +3226,7 @@
               </a:defRPr>
             </a:pPr>
             <a:r>
-              <a:t>Brazil, Mexico, Argentina, Chile, Colombia, Peru</a:t>
+              <a:t>• Germany</a:t>
             </a:r>
           </a:p>
         </p:txBody>
@@ -3239,29 +3239,29 @@
         </p:nvSpPr>
         <p:spPr>
           <a:xfrm>
-            <a:off x="457200" y="2057400"/>
-            <a:ext cx="2286000" cy="365760"/>
-          </a:xfrm>
-          <a:prstGeom prst="rect">
-            <a:avLst/>
-          </a:prstGeom>
-          <a:noFill/>
-        </p:spPr>
-        <p:txBody>
-          <a:bodyPr wrap="none">
-            <a:spAutoFit/>
-          </a:bodyPr>
-          <a:lstStyle/>
-          <a:p>
-            <a:pPr>
-              <a:defRPr sz="1400" b="1">
-                <a:solidFill>
-                  <a:srgbClr val="E8C547"/>
-                </a:solidFill>
-              </a:defRPr>
-            </a:pPr>
-            <a:r>
-              <a:t>Europe:</a:t>
+            <a:off x="457200" y="2103120"/>
+            <a:ext cx="3840480" cy="365760"/>
+          </a:xfrm>
+          <a:prstGeom prst="rect">
+            <a:avLst/>
+          </a:prstGeom>
+          <a:noFill/>
+        </p:spPr>
+        <p:txBody>
+          <a:bodyPr wrap="none">
+            <a:spAutoFit/>
+          </a:bodyPr>
+          <a:lstStyle/>
+          <a:p>
+            <a:pPr>
+              <a:defRPr sz="1300">
+                <a:solidFill>
+                  <a:srgbClr val="FFFFFF"/>
+                </a:solidFill>
+              </a:defRPr>
+            </a:pPr>
+            <a:r>
+              <a:t>• India</a:t>
             </a:r>
           </a:p>
         </p:txBody>
@@ -3274,8 +3274,8 @@
         </p:nvSpPr>
         <p:spPr>
           <a:xfrm>
-            <a:off x="2743200" y="2057400"/>
-            <a:ext cx="11430000" cy="365760"/>
+            <a:off x="457200" y="2423160"/>
+            <a:ext cx="3840480" cy="365760"/>
           </a:xfrm>
           <a:prstGeom prst="rect">
             <a:avLst/>
@@ -3296,7 +3296,7 @@
               </a:defRPr>
             </a:pPr>
             <a:r>
-              <a:t>Germany, Italy, Spain, France, Netherlands, Portugal, Austria, Belgium, Ireland, Poland, Czech Republic, Greece</a:t>
+              <a:t>• Israel</a:t>
             </a:r>
           </a:p>
         </p:txBody>
@@ -3309,29 +3309,29 @@
         </p:nvSpPr>
         <p:spPr>
           <a:xfrm>
-            <a:off x="457200" y="2468880"/>
-            <a:ext cx="2286000" cy="365760"/>
-          </a:xfrm>
-          <a:prstGeom prst="rect">
-            <a:avLst/>
-          </a:prstGeom>
-          <a:noFill/>
-        </p:spPr>
-        <p:txBody>
-          <a:bodyPr wrap="none">
-            <a:spAutoFit/>
-          </a:bodyPr>
-          <a:lstStyle/>
-          <a:p>
-            <a:pPr>
-              <a:defRPr sz="1400" b="1">
-                <a:solidFill>
-                  <a:srgbClr val="E8C547"/>
-                </a:solidFill>
-              </a:defRPr>
-            </a:pPr>
-            <a:r>
-              <a:t>Asia-Pacific:</a:t>
+            <a:off x="457200" y="2743200"/>
+            <a:ext cx="3840480" cy="365760"/>
+          </a:xfrm>
+          <a:prstGeom prst="rect">
+            <a:avLst/>
+          </a:prstGeom>
+          <a:noFill/>
+        </p:spPr>
+        <p:txBody>
+          <a:bodyPr wrap="none">
+            <a:spAutoFit/>
+          </a:bodyPr>
+          <a:lstStyle/>
+          <a:p>
+            <a:pPr>
+              <a:defRPr sz="1300">
+                <a:solidFill>
+                  <a:srgbClr val="FFFFFF"/>
+                </a:solidFill>
+              </a:defRPr>
+            </a:pPr>
+            <a:r>
+              <a:t>• Malaysia</a:t>
             </a:r>
           </a:p>
         </p:txBody>
@@ -3344,8 +3344,8 @@
         </p:nvSpPr>
         <p:spPr>
           <a:xfrm>
-            <a:off x="2743200" y="2468880"/>
-            <a:ext cx="11430000" cy="365760"/>
+            <a:off x="457200" y="3063240"/>
+            <a:ext cx="3840480" cy="365760"/>
           </a:xfrm>
           <a:prstGeom prst="rect">
             <a:avLst/>
@@ -3366,7 +3366,7 @@
               </a:defRPr>
             </a:pPr>
             <a:r>
-              <a:t>India, South Korea, Taiwan, Malaysia, Thailand</a:t>
+              <a:t>• Nigeria</a:t>
             </a:r>
           </a:p>
         </p:txBody>
@@ -3379,29 +3379,29 @@
         </p:nvSpPr>
         <p:spPr>
           <a:xfrm>
-            <a:off x="457200" y="2880360"/>
-            <a:ext cx="2286000" cy="365760"/>
-          </a:xfrm>
-          <a:prstGeom prst="rect">
-            <a:avLst/>
-          </a:prstGeom>
-          <a:noFill/>
-        </p:spPr>
-        <p:txBody>
-          <a:bodyPr wrap="none">
-            <a:spAutoFit/>
-          </a:bodyPr>
-          <a:lstStyle/>
-          <a:p>
-            <a:pPr>
-              <a:defRPr sz="1400" b="1">
-                <a:solidFill>
-                  <a:srgbClr val="E8C547"/>
-                </a:solidFill>
-              </a:defRPr>
-            </a:pPr>
-            <a:r>
-              <a:t>Middle East:</a:t>
+            <a:off x="457200" y="3383279"/>
+            <a:ext cx="3840480" cy="365760"/>
+          </a:xfrm>
+          <a:prstGeom prst="rect">
+            <a:avLst/>
+          </a:prstGeom>
+          <a:noFill/>
+        </p:spPr>
+        <p:txBody>
+          <a:bodyPr wrap="none">
+            <a:spAutoFit/>
+          </a:bodyPr>
+          <a:lstStyle/>
+          <a:p>
+            <a:pPr>
+              <a:defRPr sz="1300">
+                <a:solidFill>
+                  <a:srgbClr val="FFFFFF"/>
+                </a:solidFill>
+              </a:defRPr>
+            </a:pPr>
+            <a:r>
+              <a:t>• Oman</a:t>
             </a:r>
           </a:p>
         </p:txBody>
@@ -3414,8 +3414,8 @@
         </p:nvSpPr>
         <p:spPr>
           <a:xfrm>
-            <a:off x="2743200" y="2880360"/>
-            <a:ext cx="11430000" cy="365760"/>
+            <a:off x="457200" y="3703320"/>
+            <a:ext cx="3840480" cy="365760"/>
           </a:xfrm>
           <a:prstGeom prst="rect">
             <a:avLst/>
@@ -3436,7 +3436,7 @@
               </a:defRPr>
             </a:pPr>
             <a:r>
-              <a:t>Israel, UAE, Saudi Arabia, Qatar, Oman</a:t>
+              <a:t>• Qatar</a:t>
             </a:r>
           </a:p>
         </p:txBody>
@@ -3449,29 +3449,29 @@
         </p:nvSpPr>
         <p:spPr>
           <a:xfrm>
-            <a:off x="457200" y="3291840"/>
-            <a:ext cx="2286000" cy="365760"/>
-          </a:xfrm>
-          <a:prstGeom prst="rect">
-            <a:avLst/>
-          </a:prstGeom>
-          <a:noFill/>
-        </p:spPr>
-        <p:txBody>
-          <a:bodyPr wrap="none">
-            <a:spAutoFit/>
-          </a:bodyPr>
-          <a:lstStyle/>
-          <a:p>
-            <a:pPr>
-              <a:defRPr sz="1400" b="1">
-                <a:solidFill>
-                  <a:srgbClr val="E8C547"/>
-                </a:solidFill>
-              </a:defRPr>
-            </a:pPr>
-            <a:r>
-              <a:t>Africa:</a:t>
+            <a:off x="457200" y="4023360"/>
+            <a:ext cx="3840480" cy="365760"/>
+          </a:xfrm>
+          <a:prstGeom prst="rect">
+            <a:avLst/>
+          </a:prstGeom>
+          <a:noFill/>
+        </p:spPr>
+        <p:txBody>
+          <a:bodyPr wrap="none">
+            <a:spAutoFit/>
+          </a:bodyPr>
+          <a:lstStyle/>
+          <a:p>
+            <a:pPr>
+              <a:defRPr sz="1300">
+                <a:solidFill>
+                  <a:srgbClr val="FFFFFF"/>
+                </a:solidFill>
+              </a:defRPr>
+            </a:pPr>
+            <a:r>
+              <a:t>• Saudi Arabia</a:t>
             </a:r>
           </a:p>
         </p:txBody>
@@ -3484,8 +3484,8 @@
         </p:nvSpPr>
         <p:spPr>
           <a:xfrm>
-            <a:off x="2743200" y="3291840"/>
-            <a:ext cx="11430000" cy="365760"/>
+            <a:off x="457200" y="4343400"/>
+            <a:ext cx="3840480" cy="365760"/>
           </a:xfrm>
           <a:prstGeom prst="rect">
             <a:avLst/>
@@ -3506,7 +3506,7 @@
               </a:defRPr>
             </a:pPr>
             <a:r>
-              <a:t>Nigeria, Kenya</a:t>
+              <a:t>• South Korea</a:t>
             </a:r>
           </a:p>
         </p:txBody>
@@ -3519,29 +3519,29 @@
         </p:nvSpPr>
         <p:spPr>
           <a:xfrm>
-            <a:off x="457200" y="3703320"/>
-            <a:ext cx="2286000" cy="365760"/>
-          </a:xfrm>
-          <a:prstGeom prst="rect">
-            <a:avLst/>
-          </a:prstGeom>
-          <a:noFill/>
-        </p:spPr>
-        <p:txBody>
-          <a:bodyPr wrap="none">
-            <a:spAutoFit/>
-          </a:bodyPr>
-          <a:lstStyle/>
-          <a:p>
-            <a:pPr>
-              <a:defRPr sz="1400" b="1">
-                <a:solidFill>
-                  <a:srgbClr val="E8C547"/>
-                </a:solidFill>
-              </a:defRPr>
-            </a:pPr>
-            <a:r>
-              <a:t>North America:</a:t>
+            <a:off x="457200" y="4663440"/>
+            <a:ext cx="3840480" cy="365760"/>
+          </a:xfrm>
+          <a:prstGeom prst="rect">
+            <a:avLst/>
+          </a:prstGeom>
+          <a:noFill/>
+        </p:spPr>
+        <p:txBody>
+          <a:bodyPr wrap="none">
+            <a:spAutoFit/>
+          </a:bodyPr>
+          <a:lstStyle/>
+          <a:p>
+            <a:pPr>
+              <a:defRPr sz="1300">
+                <a:solidFill>
+                  <a:srgbClr val="FFFFFF"/>
+                </a:solidFill>
+              </a:defRPr>
+            </a:pPr>
+            <a:r>
+              <a:t>• Italy</a:t>
             </a:r>
           </a:p>
         </p:txBody>
@@ -3554,8 +3554,8 @@
         </p:nvSpPr>
         <p:spPr>
           <a:xfrm>
-            <a:off x="2743200" y="3703320"/>
-            <a:ext cx="11430000" cy="365760"/>
+            <a:off x="457200" y="4983479"/>
+            <a:ext cx="3840480" cy="365760"/>
           </a:xfrm>
           <a:prstGeom prst="rect">
             <a:avLst/>
@@ -3576,7 +3576,1022 @@
               </a:defRPr>
             </a:pPr>
             <a:r>
-              <a:t>US (14 states), Canada provinces</a:t>
+              <a:t>• Spain</a:t>
+            </a:r>
+          </a:p>
+        </p:txBody>
+      </p:sp>
+      <p:sp>
+        <p:nvSpPr>
+          <p:cNvPr id="16" name="TextBox 15"/>
+          <p:cNvSpPr txBox="1"/>
+          <p:nvPr/>
+        </p:nvSpPr>
+        <p:spPr>
+          <a:xfrm>
+            <a:off x="457200" y="5303519"/>
+            <a:ext cx="3840480" cy="365760"/>
+          </a:xfrm>
+          <a:prstGeom prst="rect">
+            <a:avLst/>
+          </a:prstGeom>
+          <a:noFill/>
+        </p:spPr>
+        <p:txBody>
+          <a:bodyPr wrap="none">
+            <a:spAutoFit/>
+          </a:bodyPr>
+          <a:lstStyle/>
+          <a:p>
+            <a:pPr>
+              <a:defRPr sz="1300">
+                <a:solidFill>
+                  <a:srgbClr val="FFFFFF"/>
+                </a:solidFill>
+              </a:defRPr>
+            </a:pPr>
+            <a:r>
+              <a:t>• France</a:t>
+            </a:r>
+          </a:p>
+        </p:txBody>
+      </p:sp>
+      <p:sp>
+        <p:nvSpPr>
+          <p:cNvPr id="17" name="TextBox 16"/>
+          <p:cNvSpPr txBox="1"/>
+          <p:nvPr/>
+        </p:nvSpPr>
+        <p:spPr>
+          <a:xfrm>
+            <a:off x="457200" y="5623560"/>
+            <a:ext cx="3840480" cy="365760"/>
+          </a:xfrm>
+          <a:prstGeom prst="rect">
+            <a:avLst/>
+          </a:prstGeom>
+          <a:noFill/>
+        </p:spPr>
+        <p:txBody>
+          <a:bodyPr wrap="none">
+            <a:spAutoFit/>
+          </a:bodyPr>
+          <a:lstStyle/>
+          <a:p>
+            <a:pPr>
+              <a:defRPr sz="1300">
+                <a:solidFill>
+                  <a:srgbClr val="FFFFFF"/>
+                </a:solidFill>
+              </a:defRPr>
+            </a:pPr>
+            <a:r>
+              <a:t>• Netherlands</a:t>
+            </a:r>
+          </a:p>
+        </p:txBody>
+      </p:sp>
+      <p:sp>
+        <p:nvSpPr>
+          <p:cNvPr id="18" name="TextBox 17"/>
+          <p:cNvSpPr txBox="1"/>
+          <p:nvPr/>
+        </p:nvSpPr>
+        <p:spPr>
+          <a:xfrm>
+            <a:off x="4572000" y="1463040"/>
+            <a:ext cx="3840480" cy="365760"/>
+          </a:xfrm>
+          <a:prstGeom prst="rect">
+            <a:avLst/>
+          </a:prstGeom>
+          <a:noFill/>
+        </p:spPr>
+        <p:txBody>
+          <a:bodyPr wrap="none">
+            <a:spAutoFit/>
+          </a:bodyPr>
+          <a:lstStyle/>
+          <a:p>
+            <a:pPr>
+              <a:defRPr sz="1300">
+                <a:solidFill>
+                  <a:srgbClr val="FFFFFF"/>
+                </a:solidFill>
+              </a:defRPr>
+            </a:pPr>
+            <a:r>
+              <a:t>• Portugal</a:t>
+            </a:r>
+          </a:p>
+        </p:txBody>
+      </p:sp>
+      <p:sp>
+        <p:nvSpPr>
+          <p:cNvPr id="19" name="TextBox 18"/>
+          <p:cNvSpPr txBox="1"/>
+          <p:nvPr/>
+        </p:nvSpPr>
+        <p:spPr>
+          <a:xfrm>
+            <a:off x="4572000" y="1783080"/>
+            <a:ext cx="3840480" cy="365760"/>
+          </a:xfrm>
+          <a:prstGeom prst="rect">
+            <a:avLst/>
+          </a:prstGeom>
+          <a:noFill/>
+        </p:spPr>
+        <p:txBody>
+          <a:bodyPr wrap="none">
+            <a:spAutoFit/>
+          </a:bodyPr>
+          <a:lstStyle/>
+          <a:p>
+            <a:pPr>
+              <a:defRPr sz="1300">
+                <a:solidFill>
+                  <a:srgbClr val="FFFFFF"/>
+                </a:solidFill>
+              </a:defRPr>
+            </a:pPr>
+            <a:r>
+              <a:t>• Taiwan</a:t>
+            </a:r>
+          </a:p>
+        </p:txBody>
+      </p:sp>
+      <p:sp>
+        <p:nvSpPr>
+          <p:cNvPr id="20" name="TextBox 19"/>
+          <p:cNvSpPr txBox="1"/>
+          <p:nvPr/>
+        </p:nvSpPr>
+        <p:spPr>
+          <a:xfrm>
+            <a:off x="4572000" y="2103120"/>
+            <a:ext cx="3840480" cy="365760"/>
+          </a:xfrm>
+          <a:prstGeom prst="rect">
+            <a:avLst/>
+          </a:prstGeom>
+          <a:noFill/>
+        </p:spPr>
+        <p:txBody>
+          <a:bodyPr wrap="none">
+            <a:spAutoFit/>
+          </a:bodyPr>
+          <a:lstStyle/>
+          <a:p>
+            <a:pPr>
+              <a:defRPr sz="1300">
+                <a:solidFill>
+                  <a:srgbClr val="FFFFFF"/>
+                </a:solidFill>
+              </a:defRPr>
+            </a:pPr>
+            <a:r>
+              <a:t>• United Arab Emirates</a:t>
+            </a:r>
+          </a:p>
+        </p:txBody>
+      </p:sp>
+      <p:sp>
+        <p:nvSpPr>
+          <p:cNvPr id="21" name="TextBox 20"/>
+          <p:cNvSpPr txBox="1"/>
+          <p:nvPr/>
+        </p:nvSpPr>
+        <p:spPr>
+          <a:xfrm>
+            <a:off x="4572000" y="2423160"/>
+            <a:ext cx="3840480" cy="365760"/>
+          </a:xfrm>
+          <a:prstGeom prst="rect">
+            <a:avLst/>
+          </a:prstGeom>
+          <a:noFill/>
+        </p:spPr>
+        <p:txBody>
+          <a:bodyPr wrap="none">
+            <a:spAutoFit/>
+          </a:bodyPr>
+          <a:lstStyle/>
+          <a:p>
+            <a:pPr>
+              <a:defRPr sz="1300">
+                <a:solidFill>
+                  <a:srgbClr val="FFFFFF"/>
+                </a:solidFill>
+              </a:defRPr>
+            </a:pPr>
+            <a:r>
+              <a:t>• United Kingdom</a:t>
+            </a:r>
+          </a:p>
+        </p:txBody>
+      </p:sp>
+      <p:sp>
+        <p:nvSpPr>
+          <p:cNvPr id="22" name="TextBox 21"/>
+          <p:cNvSpPr txBox="1"/>
+          <p:nvPr/>
+        </p:nvSpPr>
+        <p:spPr>
+          <a:xfrm>
+            <a:off x="4572000" y="2743200"/>
+            <a:ext cx="3840480" cy="365760"/>
+          </a:xfrm>
+          <a:prstGeom prst="rect">
+            <a:avLst/>
+          </a:prstGeom>
+          <a:noFill/>
+        </p:spPr>
+        <p:txBody>
+          <a:bodyPr wrap="none">
+            <a:spAutoFit/>
+          </a:bodyPr>
+          <a:lstStyle/>
+          <a:p>
+            <a:pPr>
+              <a:defRPr sz="1300">
+                <a:solidFill>
+                  <a:srgbClr val="FFFFFF"/>
+                </a:solidFill>
+              </a:defRPr>
+            </a:pPr>
+            <a:r>
+              <a:t>• British Columbia</a:t>
+            </a:r>
+          </a:p>
+        </p:txBody>
+      </p:sp>
+      <p:sp>
+        <p:nvSpPr>
+          <p:cNvPr id="23" name="TextBox 22"/>
+          <p:cNvSpPr txBox="1"/>
+          <p:nvPr/>
+        </p:nvSpPr>
+        <p:spPr>
+          <a:xfrm>
+            <a:off x="4572000" y="3063240"/>
+            <a:ext cx="3840480" cy="365760"/>
+          </a:xfrm>
+          <a:prstGeom prst="rect">
+            <a:avLst/>
+          </a:prstGeom>
+          <a:noFill/>
+        </p:spPr>
+        <p:txBody>
+          <a:bodyPr wrap="none">
+            <a:spAutoFit/>
+          </a:bodyPr>
+          <a:lstStyle/>
+          <a:p>
+            <a:pPr>
+              <a:defRPr sz="1300">
+                <a:solidFill>
+                  <a:srgbClr val="FFFFFF"/>
+                </a:solidFill>
+              </a:defRPr>
+            </a:pPr>
+            <a:r>
+              <a:t>• Alberta</a:t>
+            </a:r>
+          </a:p>
+        </p:txBody>
+      </p:sp>
+      <p:sp>
+        <p:nvSpPr>
+          <p:cNvPr id="24" name="TextBox 23"/>
+          <p:cNvSpPr txBox="1"/>
+          <p:nvPr/>
+        </p:nvSpPr>
+        <p:spPr>
+          <a:xfrm>
+            <a:off x="4572000" y="3383279"/>
+            <a:ext cx="3840480" cy="365760"/>
+          </a:xfrm>
+          <a:prstGeom prst="rect">
+            <a:avLst/>
+          </a:prstGeom>
+          <a:noFill/>
+        </p:spPr>
+        <p:txBody>
+          <a:bodyPr wrap="none">
+            <a:spAutoFit/>
+          </a:bodyPr>
+          <a:lstStyle/>
+          <a:p>
+            <a:pPr>
+              <a:defRPr sz="1300">
+                <a:solidFill>
+                  <a:srgbClr val="FFFFFF"/>
+                </a:solidFill>
+              </a:defRPr>
+            </a:pPr>
+            <a:r>
+              <a:t>• Ontario</a:t>
+            </a:r>
+          </a:p>
+        </p:txBody>
+      </p:sp>
+      <p:sp>
+        <p:nvSpPr>
+          <p:cNvPr id="25" name="TextBox 24"/>
+          <p:cNvSpPr txBox="1"/>
+          <p:nvPr/>
+        </p:nvSpPr>
+        <p:spPr>
+          <a:xfrm>
+            <a:off x="4572000" y="3703320"/>
+            <a:ext cx="3840480" cy="365760"/>
+          </a:xfrm>
+          <a:prstGeom prst="rect">
+            <a:avLst/>
+          </a:prstGeom>
+          <a:noFill/>
+        </p:spPr>
+        <p:txBody>
+          <a:bodyPr wrap="none">
+            <a:spAutoFit/>
+          </a:bodyPr>
+          <a:lstStyle/>
+          <a:p>
+            <a:pPr>
+              <a:defRPr sz="1300">
+                <a:solidFill>
+                  <a:srgbClr val="FFFFFF"/>
+                </a:solidFill>
+              </a:defRPr>
+            </a:pPr>
+            <a:r>
+              <a:t>• Quebec</a:t>
+            </a:r>
+          </a:p>
+        </p:txBody>
+      </p:sp>
+      <p:sp>
+        <p:nvSpPr>
+          <p:cNvPr id="26" name="TextBox 25"/>
+          <p:cNvSpPr txBox="1"/>
+          <p:nvPr/>
+        </p:nvSpPr>
+        <p:spPr>
+          <a:xfrm>
+            <a:off x="4572000" y="4023360"/>
+            <a:ext cx="3840480" cy="365760"/>
+          </a:xfrm>
+          <a:prstGeom prst="rect">
+            <a:avLst/>
+          </a:prstGeom>
+          <a:noFill/>
+        </p:spPr>
+        <p:txBody>
+          <a:bodyPr wrap="none">
+            <a:spAutoFit/>
+          </a:bodyPr>
+          <a:lstStyle/>
+          <a:p>
+            <a:pPr>
+              <a:defRPr sz="1300">
+                <a:solidFill>
+                  <a:srgbClr val="FFFFFF"/>
+                </a:solidFill>
+              </a:defRPr>
+            </a:pPr>
+            <a:r>
+              <a:t>• Manitoba</a:t>
+            </a:r>
+          </a:p>
+        </p:txBody>
+      </p:sp>
+      <p:sp>
+        <p:nvSpPr>
+          <p:cNvPr id="27" name="TextBox 26"/>
+          <p:cNvSpPr txBox="1"/>
+          <p:nvPr/>
+        </p:nvSpPr>
+        <p:spPr>
+          <a:xfrm>
+            <a:off x="4572000" y="4343400"/>
+            <a:ext cx="3840480" cy="365760"/>
+          </a:xfrm>
+          <a:prstGeom prst="rect">
+            <a:avLst/>
+          </a:prstGeom>
+          <a:noFill/>
+        </p:spPr>
+        <p:txBody>
+          <a:bodyPr wrap="none">
+            <a:spAutoFit/>
+          </a:bodyPr>
+          <a:lstStyle/>
+          <a:p>
+            <a:pPr>
+              <a:defRPr sz="1300">
+                <a:solidFill>
+                  <a:srgbClr val="FFFFFF"/>
+                </a:solidFill>
+              </a:defRPr>
+            </a:pPr>
+            <a:r>
+              <a:t>• Saskatchewan</a:t>
+            </a:r>
+          </a:p>
+        </p:txBody>
+      </p:sp>
+      <p:sp>
+        <p:nvSpPr>
+          <p:cNvPr id="28" name="TextBox 27"/>
+          <p:cNvSpPr txBox="1"/>
+          <p:nvPr/>
+        </p:nvSpPr>
+        <p:spPr>
+          <a:xfrm>
+            <a:off x="4572000" y="4663440"/>
+            <a:ext cx="3840480" cy="365760"/>
+          </a:xfrm>
+          <a:prstGeom prst="rect">
+            <a:avLst/>
+          </a:prstGeom>
+          <a:noFill/>
+        </p:spPr>
+        <p:txBody>
+          <a:bodyPr wrap="none">
+            <a:spAutoFit/>
+          </a:bodyPr>
+          <a:lstStyle/>
+          <a:p>
+            <a:pPr>
+              <a:defRPr sz="1300">
+                <a:solidFill>
+                  <a:srgbClr val="FFFFFF"/>
+                </a:solidFill>
+              </a:defRPr>
+            </a:pPr>
+            <a:r>
+              <a:t>• Victoria</a:t>
+            </a:r>
+          </a:p>
+        </p:txBody>
+      </p:sp>
+      <p:sp>
+        <p:nvSpPr>
+          <p:cNvPr id="29" name="TextBox 28"/>
+          <p:cNvSpPr txBox="1"/>
+          <p:nvPr/>
+        </p:nvSpPr>
+        <p:spPr>
+          <a:xfrm>
+            <a:off x="4572000" y="4983479"/>
+            <a:ext cx="3840480" cy="365760"/>
+          </a:xfrm>
+          <a:prstGeom prst="rect">
+            <a:avLst/>
+          </a:prstGeom>
+          <a:noFill/>
+        </p:spPr>
+        <p:txBody>
+          <a:bodyPr wrap="none">
+            <a:spAutoFit/>
+          </a:bodyPr>
+          <a:lstStyle/>
+          <a:p>
+            <a:pPr>
+              <a:defRPr sz="1300">
+                <a:solidFill>
+                  <a:srgbClr val="FFFFFF"/>
+                </a:solidFill>
+              </a:defRPr>
+            </a:pPr>
+            <a:r>
+              <a:t>• Louisiana</a:t>
+            </a:r>
+          </a:p>
+        </p:txBody>
+      </p:sp>
+      <p:sp>
+        <p:nvSpPr>
+          <p:cNvPr id="30" name="TextBox 29"/>
+          <p:cNvSpPr txBox="1"/>
+          <p:nvPr/>
+        </p:nvSpPr>
+        <p:spPr>
+          <a:xfrm>
+            <a:off x="4572000" y="5303519"/>
+            <a:ext cx="3840480" cy="365760"/>
+          </a:xfrm>
+          <a:prstGeom prst="rect">
+            <a:avLst/>
+          </a:prstGeom>
+          <a:noFill/>
+        </p:spPr>
+        <p:txBody>
+          <a:bodyPr wrap="none">
+            <a:spAutoFit/>
+          </a:bodyPr>
+          <a:lstStyle/>
+          <a:p>
+            <a:pPr>
+              <a:defRPr sz="1300">
+                <a:solidFill>
+                  <a:srgbClr val="FFFFFF"/>
+                </a:solidFill>
+              </a:defRPr>
+            </a:pPr>
+            <a:r>
+              <a:t>• Arizona</a:t>
+            </a:r>
+          </a:p>
+        </p:txBody>
+      </p:sp>
+      <p:sp>
+        <p:nvSpPr>
+          <p:cNvPr id="31" name="TextBox 30"/>
+          <p:cNvSpPr txBox="1"/>
+          <p:nvPr/>
+        </p:nvSpPr>
+        <p:spPr>
+          <a:xfrm>
+            <a:off x="4572000" y="5623560"/>
+            <a:ext cx="3840480" cy="365760"/>
+          </a:xfrm>
+          <a:prstGeom prst="rect">
+            <a:avLst/>
+          </a:prstGeom>
+          <a:noFill/>
+        </p:spPr>
+        <p:txBody>
+          <a:bodyPr wrap="none">
+            <a:spAutoFit/>
+          </a:bodyPr>
+          <a:lstStyle/>
+          <a:p>
+            <a:pPr>
+              <a:defRPr sz="1300">
+                <a:solidFill>
+                  <a:srgbClr val="FFFFFF"/>
+                </a:solidFill>
+              </a:defRPr>
+            </a:pPr>
+            <a:r>
+              <a:t>• Maryland</a:t>
+            </a:r>
+          </a:p>
+        </p:txBody>
+      </p:sp>
+      <p:sp>
+        <p:nvSpPr>
+          <p:cNvPr id="32" name="TextBox 31"/>
+          <p:cNvSpPr txBox="1"/>
+          <p:nvPr/>
+        </p:nvSpPr>
+        <p:spPr>
+          <a:xfrm>
+            <a:off x="8686800" y="1463040"/>
+            <a:ext cx="3840480" cy="365760"/>
+          </a:xfrm>
+          <a:prstGeom prst="rect">
+            <a:avLst/>
+          </a:prstGeom>
+          <a:noFill/>
+        </p:spPr>
+        <p:txBody>
+          <a:bodyPr wrap="none">
+            <a:spAutoFit/>
+          </a:bodyPr>
+          <a:lstStyle/>
+          <a:p>
+            <a:pPr>
+              <a:defRPr sz="1300">
+                <a:solidFill>
+                  <a:srgbClr val="FFFFFF"/>
+                </a:solidFill>
+              </a:defRPr>
+            </a:pPr>
+            <a:r>
+              <a:t>• Colorado</a:t>
+            </a:r>
+          </a:p>
+        </p:txBody>
+      </p:sp>
+      <p:sp>
+        <p:nvSpPr>
+          <p:cNvPr id="33" name="TextBox 32"/>
+          <p:cNvSpPr txBox="1"/>
+          <p:nvPr/>
+        </p:nvSpPr>
+        <p:spPr>
+          <a:xfrm>
+            <a:off x="8686800" y="1783080"/>
+            <a:ext cx="3840480" cy="365760"/>
+          </a:xfrm>
+          <a:prstGeom prst="rect">
+            <a:avLst/>
+          </a:prstGeom>
+          <a:noFill/>
+        </p:spPr>
+        <p:txBody>
+          <a:bodyPr wrap="none">
+            <a:spAutoFit/>
+          </a:bodyPr>
+          <a:lstStyle/>
+          <a:p>
+            <a:pPr>
+              <a:defRPr sz="1300">
+                <a:solidFill>
+                  <a:srgbClr val="FFFFFF"/>
+                </a:solidFill>
+              </a:defRPr>
+            </a:pPr>
+            <a:r>
+              <a:t>• Georgia</a:t>
+            </a:r>
+          </a:p>
+        </p:txBody>
+      </p:sp>
+      <p:sp>
+        <p:nvSpPr>
+          <p:cNvPr id="34" name="TextBox 33"/>
+          <p:cNvSpPr txBox="1"/>
+          <p:nvPr/>
+        </p:nvSpPr>
+        <p:spPr>
+          <a:xfrm>
+            <a:off x="8686800" y="2103120"/>
+            <a:ext cx="3840480" cy="365760"/>
+          </a:xfrm>
+          <a:prstGeom prst="rect">
+            <a:avLst/>
+          </a:prstGeom>
+          <a:noFill/>
+        </p:spPr>
+        <p:txBody>
+          <a:bodyPr wrap="none">
+            <a:spAutoFit/>
+          </a:bodyPr>
+          <a:lstStyle/>
+          <a:p>
+            <a:pPr>
+              <a:defRPr sz="1300">
+                <a:solidFill>
+                  <a:srgbClr val="FFFFFF"/>
+                </a:solidFill>
+              </a:defRPr>
+            </a:pPr>
+            <a:r>
+              <a:t>• Ohio</a:t>
+            </a:r>
+          </a:p>
+        </p:txBody>
+      </p:sp>
+      <p:sp>
+        <p:nvSpPr>
+          <p:cNvPr id="35" name="TextBox 34"/>
+          <p:cNvSpPr txBox="1"/>
+          <p:nvPr/>
+        </p:nvSpPr>
+        <p:spPr>
+          <a:xfrm>
+            <a:off x="8686800" y="2423160"/>
+            <a:ext cx="3840480" cy="365760"/>
+          </a:xfrm>
+          <a:prstGeom prst="rect">
+            <a:avLst/>
+          </a:prstGeom>
+          <a:noFill/>
+        </p:spPr>
+        <p:txBody>
+          <a:bodyPr wrap="none">
+            <a:spAutoFit/>
+          </a:bodyPr>
+          <a:lstStyle/>
+          <a:p>
+            <a:pPr>
+              <a:defRPr sz="1300">
+                <a:solidFill>
+                  <a:srgbClr val="FFFFFF"/>
+                </a:solidFill>
+              </a:defRPr>
+            </a:pPr>
+            <a:r>
+              <a:t>• California</a:t>
+            </a:r>
+          </a:p>
+        </p:txBody>
+      </p:sp>
+      <p:sp>
+        <p:nvSpPr>
+          <p:cNvPr id="36" name="TextBox 35"/>
+          <p:cNvSpPr txBox="1"/>
+          <p:nvPr/>
+        </p:nvSpPr>
+        <p:spPr>
+          <a:xfrm>
+            <a:off x="8686800" y="2743200"/>
+            <a:ext cx="3840480" cy="365760"/>
+          </a:xfrm>
+          <a:prstGeom prst="rect">
+            <a:avLst/>
+          </a:prstGeom>
+          <a:noFill/>
+        </p:spPr>
+        <p:txBody>
+          <a:bodyPr wrap="none">
+            <a:spAutoFit/>
+          </a:bodyPr>
+          <a:lstStyle/>
+          <a:p>
+            <a:pPr>
+              <a:defRPr sz="1300">
+                <a:solidFill>
+                  <a:srgbClr val="FFFFFF"/>
+                </a:solidFill>
+              </a:defRPr>
+            </a:pPr>
+            <a:r>
+              <a:t>• Utah</a:t>
+            </a:r>
+          </a:p>
+        </p:txBody>
+      </p:sp>
+      <p:sp>
+        <p:nvSpPr>
+          <p:cNvPr id="37" name="TextBox 36"/>
+          <p:cNvSpPr txBox="1"/>
+          <p:nvPr/>
+        </p:nvSpPr>
+        <p:spPr>
+          <a:xfrm>
+            <a:off x="8686800" y="3063240"/>
+            <a:ext cx="3840480" cy="365760"/>
+          </a:xfrm>
+          <a:prstGeom prst="rect">
+            <a:avLst/>
+          </a:prstGeom>
+          <a:noFill/>
+        </p:spPr>
+        <p:txBody>
+          <a:bodyPr wrap="none">
+            <a:spAutoFit/>
+          </a:bodyPr>
+          <a:lstStyle/>
+          <a:p>
+            <a:pPr>
+              <a:defRPr sz="1300">
+                <a:solidFill>
+                  <a:srgbClr val="FFFFFF"/>
+                </a:solidFill>
+              </a:defRPr>
+            </a:pPr>
+            <a:r>
+              <a:t>• Iowa</a:t>
+            </a:r>
+          </a:p>
+        </p:txBody>
+      </p:sp>
+      <p:sp>
+        <p:nvSpPr>
+          <p:cNvPr id="38" name="TextBox 37"/>
+          <p:cNvSpPr txBox="1"/>
+          <p:nvPr/>
+        </p:nvSpPr>
+        <p:spPr>
+          <a:xfrm>
+            <a:off x="8686800" y="3383279"/>
+            <a:ext cx="3840480" cy="365760"/>
+          </a:xfrm>
+          <a:prstGeom prst="rect">
+            <a:avLst/>
+          </a:prstGeom>
+          <a:noFill/>
+        </p:spPr>
+        <p:txBody>
+          <a:bodyPr wrap="none">
+            <a:spAutoFit/>
+          </a:bodyPr>
+          <a:lstStyle/>
+          <a:p>
+            <a:pPr>
+              <a:defRPr sz="1300">
+                <a:solidFill>
+                  <a:srgbClr val="FFFFFF"/>
+                </a:solidFill>
+              </a:defRPr>
+            </a:pPr>
+            <a:r>
+              <a:t>• Virginia</a:t>
+            </a:r>
+          </a:p>
+        </p:txBody>
+      </p:sp>
+      <p:sp>
+        <p:nvSpPr>
+          <p:cNvPr id="39" name="TextBox 38"/>
+          <p:cNvSpPr txBox="1"/>
+          <p:nvPr/>
+        </p:nvSpPr>
+        <p:spPr>
+          <a:xfrm>
+            <a:off x="8686800" y="3703320"/>
+            <a:ext cx="3840480" cy="365760"/>
+          </a:xfrm>
+          <a:prstGeom prst="rect">
+            <a:avLst/>
+          </a:prstGeom>
+          <a:noFill/>
+        </p:spPr>
+        <p:txBody>
+          <a:bodyPr wrap="none">
+            <a:spAutoFit/>
+          </a:bodyPr>
+          <a:lstStyle/>
+          <a:p>
+            <a:pPr>
+              <a:defRPr sz="1300">
+                <a:solidFill>
+                  <a:srgbClr val="FFFFFF"/>
+                </a:solidFill>
+              </a:defRPr>
+            </a:pPr>
+            <a:r>
+              <a:t>• Nevada</a:t>
+            </a:r>
+          </a:p>
+        </p:txBody>
+      </p:sp>
+      <p:sp>
+        <p:nvSpPr>
+          <p:cNvPr id="40" name="TextBox 39"/>
+          <p:cNvSpPr txBox="1"/>
+          <p:nvPr/>
+        </p:nvSpPr>
+        <p:spPr>
+          <a:xfrm>
+            <a:off x="8686800" y="4023360"/>
+            <a:ext cx="3840480" cy="365760"/>
+          </a:xfrm>
+          <a:prstGeom prst="rect">
+            <a:avLst/>
+          </a:prstGeom>
+          <a:noFill/>
+        </p:spPr>
+        <p:txBody>
+          <a:bodyPr wrap="none">
+            <a:spAutoFit/>
+          </a:bodyPr>
+          <a:lstStyle/>
+          <a:p>
+            <a:pPr>
+              <a:defRPr sz="1300">
+                <a:solidFill>
+                  <a:srgbClr val="FFFFFF"/>
+                </a:solidFill>
+              </a:defRPr>
+            </a:pPr>
+            <a:r>
+              <a:t>• Vermont</a:t>
+            </a:r>
+          </a:p>
+        </p:txBody>
+      </p:sp>
+      <p:sp>
+        <p:nvSpPr>
+          <p:cNvPr id="41" name="TextBox 40"/>
+          <p:cNvSpPr txBox="1"/>
+          <p:nvPr/>
+        </p:nvSpPr>
+        <p:spPr>
+          <a:xfrm>
+            <a:off x="8686800" y="4343400"/>
+            <a:ext cx="3840480" cy="365760"/>
+          </a:xfrm>
+          <a:prstGeom prst="rect">
+            <a:avLst/>
+          </a:prstGeom>
+          <a:noFill/>
+        </p:spPr>
+        <p:txBody>
+          <a:bodyPr wrap="none">
+            <a:spAutoFit/>
+          </a:bodyPr>
+          <a:lstStyle/>
+          <a:p>
+            <a:pPr>
+              <a:defRPr sz="1300">
+                <a:solidFill>
+                  <a:srgbClr val="FFFFFF"/>
+                </a:solidFill>
+              </a:defRPr>
+            </a:pPr>
+            <a:r>
+              <a:t>• New York</a:t>
+            </a:r>
+          </a:p>
+        </p:txBody>
+      </p:sp>
+      <p:sp>
+        <p:nvSpPr>
+          <p:cNvPr id="42" name="TextBox 41"/>
+          <p:cNvSpPr txBox="1"/>
+          <p:nvPr/>
+        </p:nvSpPr>
+        <p:spPr>
+          <a:xfrm>
+            <a:off x="8686800" y="4663440"/>
+            <a:ext cx="3840480" cy="365760"/>
+          </a:xfrm>
+          <a:prstGeom prst="rect">
+            <a:avLst/>
+          </a:prstGeom>
+          <a:noFill/>
+        </p:spPr>
+        <p:txBody>
+          <a:bodyPr wrap="none">
+            <a:spAutoFit/>
+          </a:bodyPr>
+          <a:lstStyle/>
+          <a:p>
+            <a:pPr>
+              <a:defRPr sz="1300">
+                <a:solidFill>
+                  <a:srgbClr val="FFFFFF"/>
+                </a:solidFill>
+              </a:defRPr>
+            </a:pPr>
+            <a:r>
+              <a:t>• New Jersey</a:t>
+            </a:r>
+          </a:p>
+        </p:txBody>
+      </p:sp>
+      <p:sp>
+        <p:nvSpPr>
+          <p:cNvPr id="43" name="TextBox 42"/>
+          <p:cNvSpPr txBox="1"/>
+          <p:nvPr/>
+        </p:nvSpPr>
+        <p:spPr>
+          <a:xfrm>
+            <a:off x="8686800" y="4983479"/>
+            <a:ext cx="3840480" cy="365760"/>
+          </a:xfrm>
+          <a:prstGeom prst="rect">
+            <a:avLst/>
+          </a:prstGeom>
+          <a:noFill/>
+        </p:spPr>
+        <p:txBody>
+          <a:bodyPr wrap="none">
+            <a:spAutoFit/>
+          </a:bodyPr>
+          <a:lstStyle/>
+          <a:p>
+            <a:pPr>
+              <a:defRPr sz="1300">
+                <a:solidFill>
+                  <a:srgbClr val="FFFFFF"/>
+                </a:solidFill>
+              </a:defRPr>
+            </a:pPr>
+            <a:r>
+              <a:t>• Texas</a:t>
+            </a:r>
+          </a:p>
+        </p:txBody>
+      </p:sp>
+      <p:sp>
+        <p:nvSpPr>
+          <p:cNvPr id="44" name="TextBox 43"/>
+          <p:cNvSpPr txBox="1"/>
+          <p:nvPr/>
+        </p:nvSpPr>
+        <p:spPr>
+          <a:xfrm>
+            <a:off x="8686800" y="5303519"/>
+            <a:ext cx="3840480" cy="365760"/>
+          </a:xfrm>
+          <a:prstGeom prst="rect">
+            <a:avLst/>
+          </a:prstGeom>
+          <a:noFill/>
+        </p:spPr>
+        <p:txBody>
+          <a:bodyPr wrap="none">
+            <a:spAutoFit/>
+          </a:bodyPr>
+          <a:lstStyle/>
+          <a:p>
+            <a:pPr>
+              <a:defRPr sz="1300">
+                <a:solidFill>
+                  <a:srgbClr val="FFFFFF"/>
+                </a:solidFill>
+              </a:defRPr>
+            </a:pPr>
+            <a:r>
+              <a:t>• Austroads</a:t>
             </a:r>
           </a:p>
         </p:txBody>
@@ -3607,16 +4622,16 @@
         </p:nvSpPr>
         <p:spPr>
           <a:xfrm>
-            <a:off x="457200" y="365760"/>
-            <a:ext cx="13716000" cy="731520"/>
-          </a:xfrm>
-          <a:prstGeom prst="rect">
-            <a:avLst/>
-          </a:prstGeom>
-          <a:noFill/>
-        </p:spPr>
-        <p:txBody>
-          <a:bodyPr wrap="square">
+            <a:off x="457200" y="274320"/>
+            <a:ext cx="13716000" cy="640080"/>
+          </a:xfrm>
+          <a:prstGeom prst="rect">
+            <a:avLst/>
+          </a:prstGeom>
+          <a:noFill/>
+        </p:spPr>
+        <p:txBody>
+          <a:bodyPr wrap="none">
             <a:spAutoFit/>
           </a:bodyPr>
           <a:lstStyle/>
@@ -3642,29 +4657,29 @@
         </p:nvSpPr>
         <p:spPr>
           <a:xfrm>
-            <a:off x="457200" y="1005840"/>
-            <a:ext cx="13716000" cy="457200"/>
-          </a:xfrm>
-          <a:prstGeom prst="rect">
-            <a:avLst/>
-          </a:prstGeom>
-          <a:noFill/>
-        </p:spPr>
-        <p:txBody>
-          <a:bodyPr wrap="none">
-            <a:spAutoFit/>
-          </a:bodyPr>
-          <a:lstStyle/>
-          <a:p>
-            <a:pPr>
-              <a:defRPr sz="2200">
+            <a:off x="457200" y="914400"/>
+            <a:ext cx="13716000" cy="365760"/>
+          </a:xfrm>
+          <a:prstGeom prst="rect">
+            <a:avLst/>
+          </a:prstGeom>
+          <a:noFill/>
+        </p:spPr>
+        <p:txBody>
+          <a:bodyPr wrap="none">
+            <a:spAutoFit/>
+          </a:bodyPr>
+          <a:lstStyle/>
+          <a:p>
+            <a:pPr>
+              <a:defRPr sz="1800">
                 <a:solidFill>
                   <a:srgbClr val="4ADE80"/>
                 </a:solidFill>
               </a:defRPr>
             </a:pPr>
             <a:r>
-              <a:t>Cloud-Based Model - Browser/app account, no physical credential issued (14 jurisdictions)</a:t>
+              <a:t>Cloud-Based Model - Browser/app account, no physical credential (5 jurisdictions)</a:t>
             </a:r>
           </a:p>
         </p:txBody>
@@ -3677,29 +4692,29 @@
         </p:nvSpPr>
         <p:spPr>
           <a:xfrm>
-            <a:off x="457200" y="1645920"/>
-            <a:ext cx="2286000" cy="365760"/>
-          </a:xfrm>
-          <a:prstGeom prst="rect">
-            <a:avLst/>
-          </a:prstGeom>
-          <a:noFill/>
-        </p:spPr>
-        <p:txBody>
-          <a:bodyPr wrap="none">
-            <a:spAutoFit/>
-          </a:bodyPr>
-          <a:lstStyle/>
-          <a:p>
-            <a:pPr>
-              <a:defRPr sz="1400" b="1">
-                <a:solidFill>
-                  <a:srgbClr val="60A5FA"/>
-                </a:solidFill>
-              </a:defRPr>
-            </a:pPr>
-            <a:r>
-              <a:t>Asia-Pacific:</a:t>
+            <a:off x="457200" y="1463040"/>
+            <a:ext cx="3840480" cy="365760"/>
+          </a:xfrm>
+          <a:prstGeom prst="rect">
+            <a:avLst/>
+          </a:prstGeom>
+          <a:noFill/>
+        </p:spPr>
+        <p:txBody>
+          <a:bodyPr wrap="none">
+            <a:spAutoFit/>
+          </a:bodyPr>
+          <a:lstStyle/>
+          <a:p>
+            <a:pPr>
+              <a:defRPr sz="1300">
+                <a:solidFill>
+                  <a:srgbClr val="FFFFFF"/>
+                </a:solidFill>
+              </a:defRPr>
+            </a:pPr>
+            <a:r>
+              <a:t>• Australia</a:t>
             </a:r>
           </a:p>
         </p:txBody>
@@ -3712,8 +4727,8 @@
         </p:nvSpPr>
         <p:spPr>
           <a:xfrm>
-            <a:off x="2743200" y="1645920"/>
-            <a:ext cx="11430000" cy="365760"/>
+            <a:off x="457200" y="1783080"/>
+            <a:ext cx="3840480" cy="365760"/>
           </a:xfrm>
           <a:prstGeom prst="rect">
             <a:avLst/>
@@ -3734,7 +4749,7 @@
               </a:defRPr>
             </a:pPr>
             <a:r>
-              <a:t>Australia (myID), Singapore (SingPass), China (Cyber ID), Hong Kong, New Zealand</a:t>
+              <a:t>• China</a:t>
             </a:r>
           </a:p>
         </p:txBody>
@@ -3747,29 +4762,29 @@
         </p:nvSpPr>
         <p:spPr>
           <a:xfrm>
-            <a:off x="457200" y="2057400"/>
-            <a:ext cx="2286000" cy="365760"/>
-          </a:xfrm>
-          <a:prstGeom prst="rect">
-            <a:avLst/>
-          </a:prstGeom>
-          <a:noFill/>
-        </p:spPr>
-        <p:txBody>
-          <a:bodyPr wrap="none">
-            <a:spAutoFit/>
-          </a:bodyPr>
-          <a:lstStyle/>
-          <a:p>
-            <a:pPr>
-              <a:defRPr sz="1400" b="1">
-                <a:solidFill>
-                  <a:srgbClr val="60A5FA"/>
-                </a:solidFill>
-              </a:defRPr>
-            </a:pPr>
-            <a:r>
-              <a:t>Europe:</a:t>
+            <a:off x="4572000" y="1463040"/>
+            <a:ext cx="3840480" cy="365760"/>
+          </a:xfrm>
+          <a:prstGeom prst="rect">
+            <a:avLst/>
+          </a:prstGeom>
+          <a:noFill/>
+        </p:spPr>
+        <p:txBody>
+          <a:bodyPr wrap="none">
+            <a:spAutoFit/>
+          </a:bodyPr>
+          <a:lstStyle/>
+          <a:p>
+            <a:pPr>
+              <a:defRPr sz="1300">
+                <a:solidFill>
+                  <a:srgbClr val="FFFFFF"/>
+                </a:solidFill>
+              </a:defRPr>
+            </a:pPr>
+            <a:r>
+              <a:t>• Kenya</a:t>
             </a:r>
           </a:p>
         </p:txBody>
@@ -3782,8 +4797,8 @@
         </p:nvSpPr>
         <p:spPr>
           <a:xfrm>
-            <a:off x="2743200" y="2057400"/>
-            <a:ext cx="11430000" cy="365760"/>
+            <a:off x="4572000" y="1783080"/>
+            <a:ext cx="3840480" cy="365760"/>
           </a:xfrm>
           <a:prstGeom prst="rect">
             <a:avLst/>
@@ -3804,7 +4819,7 @@
               </a:defRPr>
             </a:pPr>
             <a:r>
-              <a:t>UK (GOV.UK), Norway, Denmark</a:t>
+              <a:t>• Singapore</a:t>
             </a:r>
           </a:p>
         </p:txBody>
@@ -3817,43 +4832,8 @@
         </p:nvSpPr>
         <p:spPr>
           <a:xfrm>
-            <a:off x="457200" y="2468880"/>
-            <a:ext cx="2286000" cy="365760"/>
-          </a:xfrm>
-          <a:prstGeom prst="rect">
-            <a:avLst/>
-          </a:prstGeom>
-          <a:noFill/>
-        </p:spPr>
-        <p:txBody>
-          <a:bodyPr wrap="none">
-            <a:spAutoFit/>
-          </a:bodyPr>
-          <a:lstStyle/>
-          <a:p>
-            <a:pPr>
-              <a:defRPr sz="1400" b="1">
-                <a:solidFill>
-                  <a:srgbClr val="60A5FA"/>
-                </a:solidFill>
-              </a:defRPr>
-            </a:pPr>
-            <a:r>
-              <a:t>Americas:</a:t>
-            </a:r>
-          </a:p>
-        </p:txBody>
-      </p:sp>
-      <p:sp>
-        <p:nvSpPr>
-          <p:cNvPr id="9" name="TextBox 8"/>
-          <p:cNvSpPr txBox="1"/>
-          <p:nvPr/>
-        </p:nvSpPr>
-        <p:spPr>
-          <a:xfrm>
-            <a:off x="2743200" y="2468880"/>
-            <a:ext cx="11430000" cy="365760"/>
+            <a:off x="8686800" y="1463040"/>
+            <a:ext cx="3840480" cy="365760"/>
           </a:xfrm>
           <a:prstGeom prst="rect">
             <a:avLst/>
@@ -3874,77 +4854,7 @@
               </a:defRPr>
             </a:pPr>
             <a:r>
-              <a:t>Brazil (Gov.br)</a:t>
-            </a:r>
-          </a:p>
-        </p:txBody>
-      </p:sp>
-      <p:sp>
-        <p:nvSpPr>
-          <p:cNvPr id="10" name="TextBox 9"/>
-          <p:cNvSpPr txBox="1"/>
-          <p:nvPr/>
-        </p:nvSpPr>
-        <p:spPr>
-          <a:xfrm>
-            <a:off x="457200" y="2880360"/>
-            <a:ext cx="2286000" cy="365760"/>
-          </a:xfrm>
-          <a:prstGeom prst="rect">
-            <a:avLst/>
-          </a:prstGeom>
-          <a:noFill/>
-        </p:spPr>
-        <p:txBody>
-          <a:bodyPr wrap="none">
-            <a:spAutoFit/>
-          </a:bodyPr>
-          <a:lstStyle/>
-          <a:p>
-            <a:pPr>
-              <a:defRPr sz="1400" b="1">
-                <a:solidFill>
-                  <a:srgbClr val="60A5FA"/>
-                </a:solidFill>
-              </a:defRPr>
-            </a:pPr>
-            <a:r>
-              <a:t>Africa:</a:t>
-            </a:r>
-          </a:p>
-        </p:txBody>
-      </p:sp>
-      <p:sp>
-        <p:nvSpPr>
-          <p:cNvPr id="11" name="TextBox 10"/>
-          <p:cNvSpPr txBox="1"/>
-          <p:nvPr/>
-        </p:nvSpPr>
-        <p:spPr>
-          <a:xfrm>
-            <a:off x="2743200" y="2880360"/>
-            <a:ext cx="11430000" cy="365760"/>
-          </a:xfrm>
-          <a:prstGeom prst="rect">
-            <a:avLst/>
-          </a:prstGeom>
-          <a:noFill/>
-        </p:spPr>
-        <p:txBody>
-          <a:bodyPr wrap="none">
-            <a:spAutoFit/>
-          </a:bodyPr>
-          <a:lstStyle/>
-          <a:p>
-            <a:pPr>
-              <a:defRPr sz="1300">
-                <a:solidFill>
-                  <a:srgbClr val="FFFFFF"/>
-                </a:solidFill>
-              </a:defRPr>
-            </a:pPr>
-            <a:r>
-              <a:t>Kenya (eCitizen), Ghana, South Africa</a:t>
+              <a:t>• New South Wales</a:t>
             </a:r>
           </a:p>
         </p:txBody>
@@ -3975,16 +4885,16 @@
         </p:nvSpPr>
         <p:spPr>
           <a:xfrm>
-            <a:off x="457200" y="365760"/>
-            <a:ext cx="13716000" cy="731520"/>
-          </a:xfrm>
-          <a:prstGeom prst="rect">
-            <a:avLst/>
-          </a:prstGeom>
-          <a:noFill/>
-        </p:spPr>
-        <p:txBody>
-          <a:bodyPr wrap="square">
+            <a:off x="457200" y="274320"/>
+            <a:ext cx="13716000" cy="640080"/>
+          </a:xfrm>
+          <a:prstGeom prst="rect">
+            <a:avLst/>
+          </a:prstGeom>
+          <a:noFill/>
+        </p:spPr>
+        <p:txBody>
+          <a:bodyPr wrap="none">
             <a:spAutoFit/>
           </a:bodyPr>
           <a:lstStyle/>
@@ -4010,29 +4920,29 @@
         </p:nvSpPr>
         <p:spPr>
           <a:xfrm>
-            <a:off x="457200" y="1005840"/>
-            <a:ext cx="13716000" cy="457200"/>
-          </a:xfrm>
-          <a:prstGeom prst="rect">
-            <a:avLst/>
-          </a:prstGeom>
-          <a:noFill/>
-        </p:spPr>
-        <p:txBody>
-          <a:bodyPr wrap="none">
-            <a:spAutoFit/>
-          </a:bodyPr>
-          <a:lstStyle/>
-          <a:p>
-            <a:pPr>
-              <a:defRPr sz="2200">
+            <a:off x="457200" y="914400"/>
+            <a:ext cx="13716000" cy="365760"/>
+          </a:xfrm>
+          <a:prstGeom prst="rect">
+            <a:avLst/>
+          </a:prstGeom>
+          <a:noFill/>
+        </p:spPr>
+        <p:txBody>
+          <a:bodyPr wrap="none">
+            <a:spAutoFit/>
+          </a:bodyPr>
+          <a:lstStyle/>
+          <a:p>
+            <a:pPr>
+              <a:defRPr sz="1800">
                 <a:solidFill>
                   <a:srgbClr val="4ADE80"/>
                 </a:solidFill>
               </a:defRPr>
             </a:pPr>
             <a:r>
-              <a:t>Multiple Providers Model - Banks/telcos issue credentials (3 jurisdictions)</a:t>
+              <a:t>Multiple Providers Model - Banks/telcos issue credentials (4 jurisdictions)</a:t>
             </a:r>
           </a:p>
         </p:txBody>
@@ -4045,8 +4955,8 @@
         </p:nvSpPr>
         <p:spPr>
           <a:xfrm>
-            <a:off x="457200" y="1645920"/>
-            <a:ext cx="2743200" cy="365760"/>
+            <a:off x="457200" y="1463040"/>
+            <a:ext cx="3657600" cy="457200"/>
           </a:xfrm>
           <a:prstGeom prst="rect">
             <a:avLst/>
@@ -4062,12 +4972,12 @@
             <a:pPr>
               <a:defRPr sz="1400" b="1">
                 <a:solidFill>
-                  <a:srgbClr val="4ADE80"/>
-                </a:solidFill>
-              </a:defRPr>
-            </a:pPr>
-            <a:r>
-              <a:t>Estonia:</a:t>
+                  <a:srgbClr val="E8C547"/>
+                </a:solidFill>
+              </a:defRPr>
+            </a:pPr>
+            <a:r>
+              <a:t>• Estonia</a:t>
             </a:r>
           </a:p>
         </p:txBody>
@@ -4080,8 +4990,8 @@
         </p:nvSpPr>
         <p:spPr>
           <a:xfrm>
-            <a:off x="2743200" y="1645920"/>
-            <a:ext cx="10972800" cy="365760"/>
+            <a:off x="3200400" y="1463040"/>
+            <a:ext cx="10058400" cy="457200"/>
           </a:xfrm>
           <a:prstGeom prst="rect">
             <a:avLst/>
@@ -4115,8 +5025,8 @@
         </p:nvSpPr>
         <p:spPr>
           <a:xfrm>
-            <a:off x="457200" y="2103120"/>
-            <a:ext cx="2743200" cy="365760"/>
+            <a:off x="457200" y="2011680"/>
+            <a:ext cx="3657600" cy="457200"/>
           </a:xfrm>
           <a:prstGeom prst="rect">
             <a:avLst/>
@@ -4132,12 +5042,12 @@
             <a:pPr>
               <a:defRPr sz="1400" b="1">
                 <a:solidFill>
-                  <a:srgbClr val="4ADE80"/>
-                </a:solidFill>
-              </a:defRPr>
-            </a:pPr>
-            <a:r>
-              <a:t>Sweden:</a:t>
+                  <a:srgbClr val="E8C547"/>
+                </a:solidFill>
+              </a:defRPr>
+            </a:pPr>
+            <a:r>
+              <a:t>• Sweden</a:t>
             </a:r>
           </a:p>
         </p:txBody>
@@ -4150,8 +5060,8 @@
         </p:nvSpPr>
         <p:spPr>
           <a:xfrm>
-            <a:off x="2743200" y="2103120"/>
-            <a:ext cx="10972800" cy="365760"/>
+            <a:off x="3200400" y="2011680"/>
+            <a:ext cx="10058400" cy="457200"/>
           </a:xfrm>
           <a:prstGeom prst="rect">
             <a:avLst/>
@@ -4186,7 +5096,7 @@
         <p:spPr>
           <a:xfrm>
             <a:off x="457200" y="2560320"/>
-            <a:ext cx="2743200" cy="365760"/>
+            <a:ext cx="3657600" cy="457200"/>
           </a:xfrm>
           <a:prstGeom prst="rect">
             <a:avLst/>
@@ -4202,12 +5112,12 @@
             <a:pPr>
               <a:defRPr sz="1400" b="1">
                 <a:solidFill>
-                  <a:srgbClr val="4ADE80"/>
-                </a:solidFill>
-              </a:defRPr>
-            </a:pPr>
-            <a:r>
-              <a:t>Finland:</a:t>
+                  <a:srgbClr val="E8C547"/>
+                </a:solidFill>
+              </a:defRPr>
+            </a:pPr>
+            <a:r>
+              <a:t>• Finland</a:t>
             </a:r>
           </a:p>
         </p:txBody>
@@ -4220,8 +5130,8 @@
         </p:nvSpPr>
         <p:spPr>
           <a:xfrm>
-            <a:off x="2743200" y="2560320"/>
-            <a:ext cx="10972800" cy="365760"/>
+            <a:off x="3200400" y="2560320"/>
+            <a:ext cx="10058400" cy="457200"/>
           </a:xfrm>
           <a:prstGeom prst="rect">
             <a:avLst/>
@@ -4249,14 +5159,84 @@
       </p:sp>
       <p:sp>
         <p:nvSpPr>
-          <p:cNvPr id="10" name="Rounded Rectangle 9"/>
+          <p:cNvPr id="10" name="TextBox 9"/>
+          <p:cNvSpPr txBox="1"/>
+          <p:nvPr/>
+        </p:nvSpPr>
+        <p:spPr>
+          <a:xfrm>
+            <a:off x="457200" y="3108960"/>
+            <a:ext cx="3657600" cy="457200"/>
+          </a:xfrm>
+          <a:prstGeom prst="rect">
+            <a:avLst/>
+          </a:prstGeom>
+          <a:noFill/>
+        </p:spPr>
+        <p:txBody>
+          <a:bodyPr wrap="none">
+            <a:spAutoFit/>
+          </a:bodyPr>
+          <a:lstStyle/>
+          <a:p>
+            <a:pPr>
+              <a:defRPr sz="1400" b="1">
+                <a:solidFill>
+                  <a:srgbClr val="E8C547"/>
+                </a:solidFill>
+              </a:defRPr>
+            </a:pPr>
+            <a:r>
+              <a:t>• European Union</a:t>
+            </a:r>
+          </a:p>
+        </p:txBody>
+      </p:sp>
+      <p:sp>
+        <p:nvSpPr>
+          <p:cNvPr id="11" name="TextBox 10"/>
+          <p:cNvSpPr txBox="1"/>
+          <p:nvPr/>
+        </p:nvSpPr>
+        <p:spPr>
+          <a:xfrm>
+            <a:off x="3200400" y="3108960"/>
+            <a:ext cx="10058400" cy="457200"/>
+          </a:xfrm>
+          <a:prstGeom prst="rect">
+            <a:avLst/>
+          </a:prstGeom>
+          <a:noFill/>
+        </p:spPr>
+        <p:txBody>
+          <a:bodyPr wrap="none">
+            <a:spAutoFit/>
+          </a:bodyPr>
+          <a:lstStyle/>
+          <a:p>
+            <a:pPr>
+              <a:defRPr sz="1300">
+                <a:solidFill>
+                  <a:srgbClr val="FFFFFF"/>
+                </a:solidFill>
+              </a:defRPr>
+            </a:pPr>
+            <a:r>
+              <a:t>EUDI Wallet will allow multiple credentials from different issuers</a:t>
+            </a:r>
+          </a:p>
+        </p:txBody>
+      </p:sp>
+      <p:sp>
+        <p:nvSpPr>
+          <p:cNvPr id="12" name="Rounded Rectangle 11"/>
           <p:cNvSpPr/>
           <p:nvPr/>
         </p:nvSpPr>
         <p:spPr>
           <a:xfrm>
-            <a:off x="457200" y="5943600"/>
-            <a:ext cx="13716000" cy="1097280"/>
+            <a:off x="457200" y="6400800"/>
+            <a:ext cx="13716000" cy="914400"/>
           </a:xfrm>
           <a:prstGeom prst="roundRect">
             <a:avLst/>
@@ -4289,14 +5269,14 @@
           <a:lstStyle/>
           <a:p>
             <a:pPr algn="ctr">
-              <a:defRPr sz="1600">
+              <a:defRPr sz="1400">
                 <a:solidFill>
                   <a:srgbClr val="FFFFFF"/>
                 </a:solidFill>
               </a:defRPr>
             </a:pPr>
             <a:r>
-              <a:t>Key Insight: Most jurisdictions (67%) use a single issuer model. Multiple provider models are rare and typically found in Northern Europe with strong banking sectors.</a:t>
+              <a:t>Key Insight: Single issuer (67%) dominates globally. Multiple provider model is rare - strongest in Northern Europe with mature banking sectors.</a:t>
             </a:r>
           </a:p>
         </p:txBody>
@@ -4327,16 +5307,16 @@
         </p:nvSpPr>
         <p:spPr>
           <a:xfrm>
-            <a:off x="457200" y="365760"/>
-            <a:ext cx="13716000" cy="731520"/>
-          </a:xfrm>
-          <a:prstGeom prst="rect">
-            <a:avLst/>
-          </a:prstGeom>
-          <a:noFill/>
-        </p:spPr>
-        <p:txBody>
-          <a:bodyPr wrap="square">
+            <a:off x="457200" y="274320"/>
+            <a:ext cx="13716000" cy="640080"/>
+          </a:xfrm>
+          <a:prstGeom prst="rect">
+            <a:avLst/>
+          </a:prstGeom>
+          <a:noFill/>
+        </p:spPr>
+        <p:txBody>
+          <a:bodyPr wrap="none">
             <a:spAutoFit/>
           </a:bodyPr>
           <a:lstStyle/>
@@ -4362,29 +5342,29 @@
         </p:nvSpPr>
         <p:spPr>
           <a:xfrm>
-            <a:off x="457200" y="1005840"/>
-            <a:ext cx="13716000" cy="457200"/>
-          </a:xfrm>
-          <a:prstGeom prst="rect">
-            <a:avLst/>
-          </a:prstGeom>
-          <a:noFill/>
-        </p:spPr>
-        <p:txBody>
-          <a:bodyPr wrap="none">
-            <a:spAutoFit/>
-          </a:bodyPr>
-          <a:lstStyle/>
-          <a:p>
-            <a:pPr>
-              <a:defRPr sz="2200">
+            <a:off x="457200" y="914400"/>
+            <a:ext cx="13716000" cy="365760"/>
+          </a:xfrm>
+          <a:prstGeom prst="rect">
+            <a:avLst/>
+          </a:prstGeom>
+          <a:noFill/>
+        </p:spPr>
+        <p:txBody>
+          <a:bodyPr wrap="none">
+            <a:spAutoFit/>
+          </a:bodyPr>
+          <a:lstStyle/>
+          <a:p>
+            <a:pPr>
+              <a:defRPr sz="1800">
                 <a:solidFill>
                   <a:srgbClr val="4ADE80"/>
                 </a:solidFill>
               </a:defRPr>
             </a:pPr>
             <a:r>
-              <a:t>Underlying Credential Formats &amp; Protocols</a:t>
+              <a:t>Underlying Credential Formats &amp; Protocols (0 jurisdictions)</a:t>
             </a:r>
           </a:p>
         </p:txBody>
@@ -4397,8 +5377,8 @@
         </p:nvSpPr>
         <p:spPr>
           <a:xfrm>
-            <a:off x="457200" y="1828800"/>
-            <a:ext cx="3200400" cy="457200"/>
+            <a:off x="457200" y="1645920"/>
+            <a:ext cx="3657600" cy="365760"/>
           </a:xfrm>
           <a:prstGeom prst="rect">
             <a:avLst/>
@@ -4432,8 +5412,8 @@
         </p:nvSpPr>
         <p:spPr>
           <a:xfrm>
-            <a:off x="3657600" y="1828800"/>
-            <a:ext cx="7315200" cy="365760"/>
+            <a:off x="4114800" y="1645920"/>
+            <a:ext cx="6583680" cy="320040"/>
           </a:xfrm>
           <a:prstGeom prst="roundRect">
             <a:avLst/>
@@ -4477,22 +5457,22 @@
         </p:nvSpPr>
         <p:spPr>
           <a:xfrm>
-            <a:off x="11155680" y="1737360"/>
-            <a:ext cx="914400" cy="457200"/>
-          </a:xfrm>
-          <a:prstGeom prst="rect">
-            <a:avLst/>
-          </a:prstGeom>
-          <a:noFill/>
-        </p:spPr>
-        <p:txBody>
-          <a:bodyPr wrap="none">
-            <a:spAutoFit/>
-          </a:bodyPr>
-          <a:lstStyle/>
-          <a:p>
-            <a:pPr>
-              <a:defRPr sz="1400" b="1">
+            <a:off x="10881359" y="1554480"/>
+            <a:ext cx="914400" cy="365760"/>
+          </a:xfrm>
+          <a:prstGeom prst="rect">
+            <a:avLst/>
+          </a:prstGeom>
+          <a:noFill/>
+        </p:spPr>
+        <p:txBody>
+          <a:bodyPr wrap="none">
+            <a:spAutoFit/>
+          </a:bodyPr>
+          <a:lstStyle/>
+          <a:p>
+            <a:pPr>
+              <a:defRPr sz="1200" b="1">
                 <a:solidFill>
                   <a:srgbClr val="FFFFFF"/>
                 </a:solidFill>
@@ -4512,8 +5492,8 @@
         </p:nvSpPr>
         <p:spPr>
           <a:xfrm>
-            <a:off x="457200" y="2331720"/>
-            <a:ext cx="3200400" cy="457200"/>
+            <a:off x="457200" y="2103120"/>
+            <a:ext cx="3657600" cy="365760"/>
           </a:xfrm>
           <a:prstGeom prst="rect">
             <a:avLst/>
@@ -4547,18 +5527,18 @@
         </p:nvSpPr>
         <p:spPr>
           <a:xfrm>
-            <a:off x="3657600" y="2331720"/>
-            <a:ext cx="6400800" cy="365760"/>
+            <a:off x="4114800" y="2103120"/>
+            <a:ext cx="5760720" cy="320040"/>
           </a:xfrm>
           <a:prstGeom prst="roundRect">
             <a:avLst/>
           </a:prstGeom>
           <a:solidFill>
-            <a:srgbClr val="60A5FA"/>
+            <a:srgbClr val="E8C547"/>
           </a:solidFill>
           <a:ln>
             <a:solidFill>
-              <a:srgbClr val="60A5FA"/>
+              <a:srgbClr val="E8C547"/>
             </a:solidFill>
           </a:ln>
         </p:spPr>
@@ -4592,22 +5572,22 @@
         </p:nvSpPr>
         <p:spPr>
           <a:xfrm>
-            <a:off x="10241280" y="2240279"/>
-            <a:ext cx="914400" cy="457200"/>
-          </a:xfrm>
-          <a:prstGeom prst="rect">
-            <a:avLst/>
-          </a:prstGeom>
-          <a:noFill/>
-        </p:spPr>
-        <p:txBody>
-          <a:bodyPr wrap="none">
-            <a:spAutoFit/>
-          </a:bodyPr>
-          <a:lstStyle/>
-          <a:p>
-            <a:pPr>
-              <a:defRPr sz="1400" b="1">
+            <a:off x="10058400" y="2011679"/>
+            <a:ext cx="914400" cy="365760"/>
+          </a:xfrm>
+          <a:prstGeom prst="rect">
+            <a:avLst/>
+          </a:prstGeom>
+          <a:noFill/>
+        </p:spPr>
+        <p:txBody>
+          <a:bodyPr wrap="none">
+            <a:spAutoFit/>
+          </a:bodyPr>
+          <a:lstStyle/>
+          <a:p>
+            <a:pPr>
+              <a:defRPr sz="1200" b="1">
                 <a:solidFill>
                   <a:srgbClr val="FFFFFF"/>
                 </a:solidFill>
@@ -4627,8 +5607,8 @@
         </p:nvSpPr>
         <p:spPr>
           <a:xfrm>
-            <a:off x="457200" y="2834639"/>
-            <a:ext cx="3200400" cy="457200"/>
+            <a:off x="457200" y="2560320"/>
+            <a:ext cx="3657600" cy="365760"/>
           </a:xfrm>
           <a:prstGeom prst="rect">
             <a:avLst/>
@@ -4662,18 +5642,18 @@
         </p:nvSpPr>
         <p:spPr>
           <a:xfrm>
-            <a:off x="3657600" y="2834639"/>
-            <a:ext cx="2743200" cy="365760"/>
+            <a:off x="4114800" y="2560320"/>
+            <a:ext cx="2468879" cy="320040"/>
           </a:xfrm>
           <a:prstGeom prst="roundRect">
             <a:avLst/>
           </a:prstGeom>
           <a:solidFill>
-            <a:srgbClr val="FBBF24"/>
+            <a:srgbClr val="E8C547"/>
           </a:solidFill>
           <a:ln>
             <a:solidFill>
-              <a:srgbClr val="FBBF24"/>
+              <a:srgbClr val="E8C547"/>
             </a:solidFill>
           </a:ln>
         </p:spPr>
@@ -4707,22 +5687,22 @@
         </p:nvSpPr>
         <p:spPr>
           <a:xfrm>
-            <a:off x="6583680" y="2743199"/>
-            <a:ext cx="914400" cy="457200"/>
-          </a:xfrm>
-          <a:prstGeom prst="rect">
-            <a:avLst/>
-          </a:prstGeom>
-          <a:noFill/>
-        </p:spPr>
-        <p:txBody>
-          <a:bodyPr wrap="none">
-            <a:spAutoFit/>
-          </a:bodyPr>
-          <a:lstStyle/>
-          <a:p>
-            <a:pPr>
-              <a:defRPr sz="1400" b="1">
+            <a:off x="6766559" y="2468879"/>
+            <a:ext cx="914400" cy="365760"/>
+          </a:xfrm>
+          <a:prstGeom prst="rect">
+            <a:avLst/>
+          </a:prstGeom>
+          <a:noFill/>
+        </p:spPr>
+        <p:txBody>
+          <a:bodyPr wrap="none">
+            <a:spAutoFit/>
+          </a:bodyPr>
+          <a:lstStyle/>
+          <a:p>
+            <a:pPr>
+              <a:defRPr sz="1200" b="1">
                 <a:solidFill>
                   <a:srgbClr val="FFFFFF"/>
                 </a:solidFill>
@@ -4742,8 +5722,8 @@
         </p:nvSpPr>
         <p:spPr>
           <a:xfrm>
-            <a:off x="457200" y="3337559"/>
-            <a:ext cx="3200400" cy="457200"/>
+            <a:off x="457200" y="3017520"/>
+            <a:ext cx="3657600" cy="365760"/>
           </a:xfrm>
           <a:prstGeom prst="rect">
             <a:avLst/>
@@ -4777,18 +5757,18 @@
         </p:nvSpPr>
         <p:spPr>
           <a:xfrm>
-            <a:off x="3657600" y="3337559"/>
-            <a:ext cx="1828800" cy="365760"/>
+            <a:off x="4114800" y="3017520"/>
+            <a:ext cx="1645920" cy="320040"/>
           </a:xfrm>
           <a:prstGeom prst="roundRect">
             <a:avLst/>
           </a:prstGeom>
           <a:solidFill>
-            <a:srgbClr val="FBBF24"/>
+            <a:srgbClr val="E8C547"/>
           </a:solidFill>
           <a:ln>
             <a:solidFill>
-              <a:srgbClr val="FBBF24"/>
+              <a:srgbClr val="E8C547"/>
             </a:solidFill>
           </a:ln>
         </p:spPr>
@@ -4822,22 +5802,22 @@
         </p:nvSpPr>
         <p:spPr>
           <a:xfrm>
-            <a:off x="5669280" y="3246119"/>
-            <a:ext cx="914400" cy="457200"/>
-          </a:xfrm>
-          <a:prstGeom prst="rect">
-            <a:avLst/>
-          </a:prstGeom>
-          <a:noFill/>
-        </p:spPr>
-        <p:txBody>
-          <a:bodyPr wrap="none">
-            <a:spAutoFit/>
-          </a:bodyPr>
-          <a:lstStyle/>
-          <a:p>
-            <a:pPr>
-              <a:defRPr sz="1400" b="1">
+            <a:off x="5943600" y="2926079"/>
+            <a:ext cx="914400" cy="365760"/>
+          </a:xfrm>
+          <a:prstGeom prst="rect">
+            <a:avLst/>
+          </a:prstGeom>
+          <a:noFill/>
+        </p:spPr>
+        <p:txBody>
+          <a:bodyPr wrap="none">
+            <a:spAutoFit/>
+          </a:bodyPr>
+          <a:lstStyle/>
+          <a:p>
+            <a:pPr>
+              <a:defRPr sz="1200" b="1">
                 <a:solidFill>
                   <a:srgbClr val="FFFFFF"/>
                 </a:solidFill>
@@ -4857,8 +5837,8 @@
         </p:nvSpPr>
         <p:spPr>
           <a:xfrm>
-            <a:off x="457200" y="3840479"/>
-            <a:ext cx="3200400" cy="457200"/>
+            <a:off x="457200" y="3474720"/>
+            <a:ext cx="3657600" cy="365760"/>
           </a:xfrm>
           <a:prstGeom prst="rect">
             <a:avLst/>
@@ -4892,18 +5872,18 @@
         </p:nvSpPr>
         <p:spPr>
           <a:xfrm>
-            <a:off x="3657600" y="3840479"/>
-            <a:ext cx="1371600" cy="365760"/>
+            <a:off x="4114800" y="3474720"/>
+            <a:ext cx="1234439" cy="320040"/>
           </a:xfrm>
           <a:prstGeom prst="roundRect">
             <a:avLst/>
           </a:prstGeom>
           <a:solidFill>
-            <a:srgbClr val="60A5FA"/>
+            <a:srgbClr val="E8C547"/>
           </a:solidFill>
           <a:ln>
             <a:solidFill>
-              <a:srgbClr val="60A5FA"/>
+              <a:srgbClr val="E8C547"/>
             </a:solidFill>
           </a:ln>
         </p:spPr>
@@ -4937,22 +5917,22 @@
         </p:nvSpPr>
         <p:spPr>
           <a:xfrm>
-            <a:off x="5212080" y="3749039"/>
-            <a:ext cx="914400" cy="457200"/>
-          </a:xfrm>
-          <a:prstGeom prst="rect">
-            <a:avLst/>
-          </a:prstGeom>
-          <a:noFill/>
-        </p:spPr>
-        <p:txBody>
-          <a:bodyPr wrap="none">
-            <a:spAutoFit/>
-          </a:bodyPr>
-          <a:lstStyle/>
-          <a:p>
-            <a:pPr>
-              <a:defRPr sz="1400" b="1">
+            <a:off x="5532120" y="3383279"/>
+            <a:ext cx="914400" cy="365760"/>
+          </a:xfrm>
+          <a:prstGeom prst="rect">
+            <a:avLst/>
+          </a:prstGeom>
+          <a:noFill/>
+        </p:spPr>
+        <p:txBody>
+          <a:bodyPr wrap="none">
+            <a:spAutoFit/>
+          </a:bodyPr>
+          <a:lstStyle/>
+          <a:p>
+            <a:pPr>
+              <a:defRPr sz="1200" b="1">
                 <a:solidFill>
                   <a:srgbClr val="FFFFFF"/>
                 </a:solidFill>
@@ -4972,8 +5952,8 @@
         </p:nvSpPr>
         <p:spPr>
           <a:xfrm>
-            <a:off x="457200" y="4343399"/>
-            <a:ext cx="3200400" cy="457200"/>
+            <a:off x="457200" y="3931920"/>
+            <a:ext cx="3657600" cy="365760"/>
           </a:xfrm>
           <a:prstGeom prst="rect">
             <a:avLst/>
@@ -5007,18 +5987,18 @@
         </p:nvSpPr>
         <p:spPr>
           <a:xfrm>
-            <a:off x="3657600" y="4343399"/>
-            <a:ext cx="914400" cy="365760"/>
+            <a:off x="4114800" y="3931920"/>
+            <a:ext cx="822960" cy="320040"/>
           </a:xfrm>
           <a:prstGeom prst="roundRect">
             <a:avLst/>
           </a:prstGeom>
           <a:solidFill>
-            <a:srgbClr val="60A5FA"/>
+            <a:srgbClr val="E8C547"/>
           </a:solidFill>
           <a:ln>
             <a:solidFill>
-              <a:srgbClr val="60A5FA"/>
+              <a:srgbClr val="E8C547"/>
             </a:solidFill>
           </a:ln>
         </p:spPr>
@@ -5052,22 +6032,22 @@
         </p:nvSpPr>
         <p:spPr>
           <a:xfrm>
-            <a:off x="4754880" y="4251959"/>
-            <a:ext cx="914400" cy="457200"/>
-          </a:xfrm>
-          <a:prstGeom prst="rect">
-            <a:avLst/>
-          </a:prstGeom>
-          <a:noFill/>
-        </p:spPr>
-        <p:txBody>
-          <a:bodyPr wrap="none">
-            <a:spAutoFit/>
-          </a:bodyPr>
-          <a:lstStyle/>
-          <a:p>
-            <a:pPr>
-              <a:defRPr sz="1400" b="1">
+            <a:off x="5120640" y="3840480"/>
+            <a:ext cx="914400" cy="365760"/>
+          </a:xfrm>
+          <a:prstGeom prst="rect">
+            <a:avLst/>
+          </a:prstGeom>
+          <a:noFill/>
+        </p:spPr>
+        <p:txBody>
+          <a:bodyPr wrap="none">
+            <a:spAutoFit/>
+          </a:bodyPr>
+          <a:lstStyle/>
+          <a:p>
+            <a:pPr>
+              <a:defRPr sz="1200" b="1">
                 <a:solidFill>
                   <a:srgbClr val="FFFFFF"/>
                 </a:solidFill>
@@ -5087,8 +6067,8 @@
         </p:nvSpPr>
         <p:spPr>
           <a:xfrm>
-            <a:off x="457200" y="4846319"/>
-            <a:ext cx="3200400" cy="457200"/>
+            <a:off x="457200" y="4389120"/>
+            <a:ext cx="3657600" cy="365760"/>
           </a:xfrm>
           <a:prstGeom prst="rect">
             <a:avLst/>
@@ -5122,18 +6102,18 @@
         </p:nvSpPr>
         <p:spPr>
           <a:xfrm>
-            <a:off x="3657600" y="4846319"/>
-            <a:ext cx="914400" cy="365760"/>
+            <a:off x="4114800" y="4389120"/>
+            <a:ext cx="822960" cy="320040"/>
           </a:xfrm>
           <a:prstGeom prst="roundRect">
             <a:avLst/>
           </a:prstGeom>
           <a:solidFill>
-            <a:srgbClr val="60A5FA"/>
+            <a:srgbClr val="E8C547"/>
           </a:solidFill>
           <a:ln>
             <a:solidFill>
-              <a:srgbClr val="60A5FA"/>
+              <a:srgbClr val="E8C547"/>
             </a:solidFill>
           </a:ln>
         </p:spPr>
@@ -5167,22 +6147,22 @@
         </p:nvSpPr>
         <p:spPr>
           <a:xfrm>
-            <a:off x="4754880" y="4754879"/>
-            <a:ext cx="914400" cy="457200"/>
-          </a:xfrm>
-          <a:prstGeom prst="rect">
-            <a:avLst/>
-          </a:prstGeom>
-          <a:noFill/>
-        </p:spPr>
-        <p:txBody>
-          <a:bodyPr wrap="none">
-            <a:spAutoFit/>
-          </a:bodyPr>
-          <a:lstStyle/>
-          <a:p>
-            <a:pPr>
-              <a:defRPr sz="1400" b="1">
+            <a:off x="5120640" y="4297680"/>
+            <a:ext cx="914400" cy="365760"/>
+          </a:xfrm>
+          <a:prstGeom prst="rect">
+            <a:avLst/>
+          </a:prstGeom>
+          <a:noFill/>
+        </p:spPr>
+        <p:txBody>
+          <a:bodyPr wrap="none">
+            <a:spAutoFit/>
+          </a:bodyPr>
+          <a:lstStyle/>
+          <a:p>
+            <a:pPr>
+              <a:defRPr sz="1200" b="1">
                 <a:solidFill>
                   <a:srgbClr val="FFFFFF"/>
                 </a:solidFill>
@@ -5190,60 +6170,6 @@
             </a:pPr>
             <a:r>
               <a:t>2</a:t>
-            </a:r>
-          </a:p>
-        </p:txBody>
-      </p:sp>
-      <p:sp>
-        <p:nvSpPr>
-          <p:cNvPr id="25" name="Rounded Rectangle 24"/>
-          <p:cNvSpPr/>
-          <p:nvPr/>
-        </p:nvSpPr>
-        <p:spPr>
-          <a:xfrm>
-            <a:off x="457200" y="6217920"/>
-            <a:ext cx="13716000" cy="1097280"/>
-          </a:xfrm>
-          <a:prstGeom prst="roundRect">
-            <a:avLst/>
-          </a:prstGeom>
-          <a:solidFill>
-            <a:srgbClr val="16213E"/>
-          </a:solidFill>
-          <a:ln>
-            <a:solidFill>
-              <a:srgbClr val="E8C547"/>
-            </a:solidFill>
-          </a:ln>
-        </p:spPr>
-        <p:style>
-          <a:lnRef idx="1">
-            <a:schemeClr val="accent1"/>
-          </a:lnRef>
-          <a:fillRef idx="3">
-            <a:schemeClr val="accent1"/>
-          </a:fillRef>
-          <a:effectRef idx="2">
-            <a:schemeClr val="accent1"/>
-          </a:effectRef>
-          <a:fontRef idx="minor">
-            <a:schemeClr val="lt1"/>
-          </a:fontRef>
-        </p:style>
-        <p:txBody>
-          <a:bodyPr rtlCol="0" anchor="ctr"/>
-          <a:lstStyle/>
-          <a:p>
-            <a:pPr algn="ctr">
-              <a:defRPr sz="1400">
-                <a:solidFill>
-                  <a:srgbClr val="FFFFFF"/>
-                </a:solidFill>
-              </a:defRPr>
-            </a:pPr>
-            <a:r>
-              <a:t>Emerging Trend: ISO 18013-5 (mobile Driver License) is the most common format in the US. EUDI Wallet adoption accelerating in Europe with 2026 deadline.</a:t>
             </a:r>
           </a:p>
         </p:txBody>

</xml_diff>